<commit_message>
Build advisor backend and screens (specs 20-27)
Advisor dashboard, advisees, student record, approvals queue, meetings,
messages, reports and settings: FastAPI services, routers, schemas, seed
data and tests, plus the matching React screens and shared components.
Also adds the Sprint 2 task planning sheet and updated Sprint 1 deck.

Co-Authored-By: Claude Opus 5.5 <noreply@anthropic.com>
</commit_message>
<xml_diff>
--- a/Doumentation/Presentaions/AcadMate_Sprint1_Presentation.pptx
+++ b/Doumentation/Presentaions/AcadMate_Sprint1_Presentation.pptx
@@ -149,21 +149,12 @@
 </p:presentation>
 </file>
 
-<file path=ppt/revisionInfo.xml><?xml version="1.0" encoding="utf-8"?>
-<p1510:revInfo xmlns:a="http://schemas.openxmlformats.org/drawingml/2006/main" xmlns:r="http://schemas.openxmlformats.org/officeDocument/2006/relationships" xmlns:p1510="http://schemas.microsoft.com/office/powerpoint/2015/10/main">
-  <p1510:revLst>
-    <p1510:client id="{EF004288-9F56-4A3F-91C9-30ABA586B2DD}" v="15" dt="2026-10-19T09:56:00.744"/>
-    <p1510:client id="{F2253596-AAD1-4781-A4EA-97102005E06D}" v="1" dt="2026-10-18T15:41:25.751"/>
-  </p1510:revLst>
-</p1510:revInfo>
-</file>
-
 <file path=ppt/changesInfos/changesInfo1.xml><?xml version="1.0" encoding="utf-8"?>
 <pc:chgInfo xmlns:a="http://schemas.openxmlformats.org/drawingml/2006/main" xmlns:r="http://schemas.openxmlformats.org/officeDocument/2006/relationships" xmlns:ac="http://schemas.microsoft.com/office/drawing/2013/main/command" xmlns:pc="http://schemas.microsoft.com/office/powerpoint/2013/main/command">
   <pc:docChgLst>
     <pc:chgData name="Pranali Dukhande" userId="0ae46a4f0aa76adb" providerId="LiveId" clId="{DA6FBA60-F893-443A-AEE5-71C6A73E4BD7}"/>
-    <pc:docChg chg="undo custSel addSld modSld">
-      <pc:chgData name="Pranali Dukhande" userId="0ae46a4f0aa76adb" providerId="LiveId" clId="{DA6FBA60-F893-443A-AEE5-71C6A73E4BD7}" dt="2026-10-19T09:54:21.312" v="116" actId="255"/>
+    <pc:docChg chg="undo custSel addSld modSld modShowInfo">
+      <pc:chgData name="Pranali Dukhande" userId="0ae46a4f0aa76adb" providerId="LiveId" clId="{DA6FBA60-F893-443A-AEE5-71C6A73E4BD7}" dt="2026-10-20T22:15:16.580" v="134" actId="1035"/>
       <pc:docMkLst>
         <pc:docMk/>
       </pc:docMkLst>
@@ -505,7 +496,7 @@
         </pc:picChg>
       </pc:sldChg>
       <pc:sldChg chg="addSp delSp modSp add mod">
-        <pc:chgData name="Pranali Dukhande" userId="0ae46a4f0aa76adb" providerId="LiveId" clId="{DA6FBA60-F893-443A-AEE5-71C6A73E4BD7}" dt="2026-10-19T09:52:25.005" v="79" actId="20577"/>
+        <pc:chgData name="Pranali Dukhande" userId="0ae46a4f0aa76adb" providerId="LiveId" clId="{DA6FBA60-F893-443A-AEE5-71C6A73E4BD7}" dt="2026-10-20T22:15:16.580" v="134" actId="1035"/>
         <pc:sldMkLst>
           <pc:docMk/>
           <pc:sldMk cId="3323812862" sldId="279"/>
@@ -543,7 +534,7 @@
           </ac:picMkLst>
         </pc:picChg>
         <pc:picChg chg="add mod">
-          <ac:chgData name="Pranali Dukhande" userId="0ae46a4f0aa76adb" providerId="LiveId" clId="{DA6FBA60-F893-443A-AEE5-71C6A73E4BD7}" dt="2026-10-19T09:47:47.213" v="59" actId="1076"/>
+          <ac:chgData name="Pranali Dukhande" userId="0ae46a4f0aa76adb" providerId="LiveId" clId="{DA6FBA60-F893-443A-AEE5-71C6A73E4BD7}" dt="2026-10-20T22:15:16.580" v="134" actId="1035"/>
           <ac:picMkLst>
             <pc:docMk/>
             <pc:sldMk cId="3323812862" sldId="279"/>
@@ -1622,7 +1613,7 @@
           <a:p>
             <a:fld id="{BD8ED843-09BC-4804-A240-9A6F1BDF675D}" type="datetimeFigureOut">
               <a:rPr lang="en-IN" smtClean="0"/>
-              <a:t>19-10-2026</a:t>
+              <a:t>20-10-2026</a:t>
             </a:fld>
             <a:endParaRPr lang="en-IN"/>
           </a:p>
@@ -2459,7 +2450,7 @@
           <a:p>
             <a:fld id="{7F5B18FE-FC05-409D-ABB6-B289E96633D4}" type="datetime1">
               <a:rPr lang="en-US" smtClean="0"/>
-              <a:t>10/19/2026</a:t>
+              <a:t>10/20/2026</a:t>
             </a:fld>
             <a:endParaRPr lang="en-US"/>
           </a:p>
@@ -2627,7 +2618,7 @@
           <a:p>
             <a:fld id="{9E1D8201-D272-4BD5-8C4D-4DB9F4FB2D07}" type="datetime1">
               <a:rPr lang="en-US" smtClean="0"/>
-              <a:t>10/19/2026</a:t>
+              <a:t>10/20/2026</a:t>
             </a:fld>
             <a:endParaRPr lang="en-US"/>
           </a:p>
@@ -2805,7 +2796,7 @@
           <a:p>
             <a:fld id="{D8B3E7A6-09B1-4BC2-A3A9-236C9ED4CE59}" type="datetime1">
               <a:rPr lang="en-US" smtClean="0"/>
-              <a:t>10/19/2026</a:t>
+              <a:t>10/20/2026</a:t>
             </a:fld>
             <a:endParaRPr lang="en-US"/>
           </a:p>
@@ -3238,7 +3229,7 @@
           <a:p>
             <a:fld id="{3F78B0D6-4091-4724-8A22-CA6142E4E2BE}" type="datetime1">
               <a:rPr lang="en-US" smtClean="0"/>
-              <a:t>10/19/2026</a:t>
+              <a:t>10/20/2026</a:t>
             </a:fld>
             <a:endParaRPr lang="en-US"/>
           </a:p>
@@ -3483,7 +3474,7 @@
           <a:p>
             <a:fld id="{0BCA5599-5D2E-45F8-859F-500BA58C64E7}" type="datetime1">
               <a:rPr lang="en-US" smtClean="0"/>
-              <a:t>10/19/2026</a:t>
+              <a:t>10/20/2026</a:t>
             </a:fld>
             <a:endParaRPr lang="en-US"/>
           </a:p>
@@ -3768,7 +3759,7 @@
           <a:p>
             <a:fld id="{83BE6D80-F48A-4B0D-B676-CE8EF496A61B}" type="datetime1">
               <a:rPr lang="en-US" smtClean="0"/>
-              <a:t>10/19/2026</a:t>
+              <a:t>10/20/2026</a:t>
             </a:fld>
             <a:endParaRPr lang="en-US"/>
           </a:p>
@@ -4187,7 +4178,7 @@
           <a:p>
             <a:fld id="{83CC01DA-B626-43EB-A094-82A4C246A984}" type="datetime1">
               <a:rPr lang="en-US" smtClean="0"/>
-              <a:t>10/19/2026</a:t>
+              <a:t>10/20/2026</a:t>
             </a:fld>
             <a:endParaRPr lang="en-US"/>
           </a:p>
@@ -4304,7 +4295,7 @@
           <a:p>
             <a:fld id="{1DD0D66D-C74C-41A8-A917-E757602EECBD}" type="datetime1">
               <a:rPr lang="en-US" smtClean="0"/>
-              <a:t>10/19/2026</a:t>
+              <a:t>10/20/2026</a:t>
             </a:fld>
             <a:endParaRPr lang="en-US"/>
           </a:p>
@@ -4399,7 +4390,7 @@
           <a:p>
             <a:fld id="{6142C43F-2DCD-4FEF-9A7C-48E8498C4D25}" type="datetime1">
               <a:rPr lang="en-US" smtClean="0"/>
-              <a:t>10/19/2026</a:t>
+              <a:t>10/20/2026</a:t>
             </a:fld>
             <a:endParaRPr lang="en-US"/>
           </a:p>
@@ -4674,7 +4665,7 @@
           <a:p>
             <a:fld id="{ABCB46BD-846E-4FE8-A4A4-4FF9EF0C5AD3}" type="datetime1">
               <a:rPr lang="en-US" smtClean="0"/>
-              <a:t>10/19/2026</a:t>
+              <a:t>10/20/2026</a:t>
             </a:fld>
             <a:endParaRPr lang="en-US"/>
           </a:p>
@@ -4926,7 +4917,7 @@
           <a:p>
             <a:fld id="{78E01D3E-D14C-49A2-872D-A7ABFB2234F7}" type="datetime1">
               <a:rPr lang="en-US" smtClean="0"/>
-              <a:t>10/19/2026</a:t>
+              <a:t>10/20/2026</a:t>
             </a:fld>
             <a:endParaRPr lang="en-US"/>
           </a:p>
@@ -5137,7 +5128,7 @@
           <a:p>
             <a:fld id="{01AFDCB2-9972-450E-94BE-527CD3F1333B}" type="datetime1">
               <a:rPr lang="en-US" smtClean="0"/>
-              <a:t>10/19/2026</a:t>
+              <a:t>10/20/2026</a:t>
             </a:fld>
             <a:endParaRPr lang="en-US"/>
           </a:p>
@@ -6823,7 +6814,7 @@
         </p:blipFill>
         <p:spPr>
           <a:xfrm>
-            <a:off x="973394" y="2165902"/>
+            <a:off x="963234" y="2023662"/>
             <a:ext cx="10993690" cy="2668004"/>
           </a:xfrm>
           <a:prstGeom prst="rect">

</xml_diff>